<commit_message>
Dört deneyim türü slaydı daire düzenine çevrildi
"Mağazanın sunabileceği dört deneyim türü" slaydı kutu düzeninden,
bir önceki "Deneyim neyden oluşur" slaydıyla aynı daire düzenine
alındı; ikisi artık birbirinin devamı olarak okunuyor.

Her dairenin altında açıklama, onun altında "mekânsal talep" satırı
var: deneyim türünün mekândan ne istediği.

Slayt ayrıca tek başına Dort-Deneyim-Turu.pptx olarak da eklendi.

Co-Authored-By: Claude Opus 5 <noreply@anthropic.com>
Claude-Session: https://claude.ai/code/session_012829GnztWNW7AgpXkSZZYk
</commit_message>
<xml_diff>
--- a/magaza-tasarimi-dersi/Magaza-Tasarimi-Teorik-Sunum.pptx
+++ b/magaza-tasarimi-dersi/Magaza-Tasarimi-Teorik-Sunum.pptx
@@ -733,7 +733,7 @@
           <a:p>
             <a:r>
               <a:rPr lang="en-US" dirty="0"/>
-              <a:t>Öğrencilerin markasına hangi deneyim türünün uyduğunu düşündürün — bu, konsept kararını doğrudan besler.</a:t>
+              <a:t>Bir önceki slaydın devamı: orada deneyimin neyden oluştuğu, burada hangi biçimlerde kurulabileceği anlatılıyor. Öğrencilere kendi markalarına hangi türün uyduğunu düşündürün — bu, konsept kararını doğrudan besliyor.</a:t>
             </a:r>
             <a:endParaRPr lang="en-US" dirty="0"/>
           </a:p>
@@ -6871,8 +6871,8 @@
         </p:nvSpPr>
         <p:spPr>
           <a:xfrm>
-            <a:off x="777240" y="1627632"/>
-            <a:ext cx="10634472" cy="594360"/>
+            <a:off x="777240" y="1572768"/>
+            <a:ext cx="10634472" cy="914400"/>
           </a:xfrm>
           <a:prstGeom prst="rect">
             <a:avLst/>
@@ -6899,7 +6899,7 @@
                 <a:ea typeface="Cambria" pitchFamily="34" charset="-122"/>
                 <a:cs typeface="Cambria" pitchFamily="34" charset="-120"/>
               </a:rPr>
-              <a:t>Mağaza deneyimi tek bir biçimde kurulmaz. Aşağıdaki dört tür farklı mekânsal talepler üretir ve bir mağaza bunlardan yalnızca birini ya da birkaçını seçer.</a:t>
+              <a:t>Deneyim tek bir biçimde kurulmaz. Aşağıdaki dört tür, müşterinin mağazada ne yaptığına göre ayrışır ve her biri mekândan farklı bir şey ister. Bir mağaza dördünü birden iyi yapamaz; hangisini seçtiği bir tasarım kararıdır.</a:t>
             </a:r>
             <a:endParaRPr lang="en-US" sz="1500" dirty="0"/>
           </a:p>
@@ -6913,13 +6913,204 @@
         </p:nvSpPr>
         <p:spPr>
           <a:xfrm>
-            <a:off x="777240" y="2514600"/>
-            <a:ext cx="2487168" cy="2240280"/>
-          </a:xfrm>
-          <a:prstGeom prst="rect">
-            <a:avLst/>
-          </a:prstGeom>
-          <a:ln w="9525">
+            <a:off x="1362456" y="2368296"/>
+            <a:ext cx="1572768" cy="1572768"/>
+          </a:xfrm>
+          <a:prstGeom prst="ellipse">
+            <a:avLst/>
+          </a:prstGeom>
+          <a:solidFill>
+            <a:srgbClr val="F6EAE6"/>
+          </a:solidFill>
+          <a:ln w="19050">
+            <a:solidFill>
+              <a:srgbClr val="8C3A2B"/>
+            </a:solidFill>
+            <a:prstDash val="solid"/>
+          </a:ln>
+        </p:spPr>
+      </p:sp>
+      <p:sp>
+        <p:nvSpPr>
+          <p:cNvPr id="7" name="Text 5"/>
+          <p:cNvSpPr txBox="1"/>
+          <p:nvPr/>
+        </p:nvSpPr>
+        <p:spPr>
+          <a:xfrm>
+            <a:off x="1362456" y="2743200"/>
+            <a:ext cx="1572768" cy="822960"/>
+          </a:xfrm>
+          <a:prstGeom prst="rect">
+            <a:avLst/>
+          </a:prstGeom>
+          <a:noFill/>
+          <a:ln/>
+        </p:spPr>
+        <p:txBody>
+          <a:bodyPr wrap="square" lIns="0" tIns="0" rIns="0" bIns="0" rtlCol="0" anchor="ctr"/>
+          <a:lstStyle/>
+          <a:p>
+            <a:pPr algn="ctr" indent="0" marL="0">
+              <a:lnSpc>
+                <a:spcPts val="1400"/>
+              </a:lnSpc>
+              <a:buNone/>
+            </a:pPr>
+            <a:r>
+              <a:rPr lang="en-US" sz="1100" b="1" dirty="0">
+                <a:solidFill>
+                  <a:srgbClr val="8C3A2B"/>
+                </a:solidFill>
+                <a:latin typeface="Calibri" pitchFamily="34" charset="0"/>
+                <a:ea typeface="Calibri" pitchFamily="34" charset="-122"/>
+                <a:cs typeface="Calibri" pitchFamily="34" charset="-120"/>
+              </a:rPr>
+              <a:t>Öğrenme</a:t>
+            </a:r>
+            <a:endParaRPr lang="en-US" sz="1100" dirty="0"/>
+          </a:p>
+        </p:txBody>
+      </p:sp>
+      <p:sp>
+        <p:nvSpPr>
+          <p:cNvPr id="8" name="Text 6"/>
+          <p:cNvSpPr txBox="1"/>
+          <p:nvPr/>
+        </p:nvSpPr>
+        <p:spPr>
+          <a:xfrm>
+            <a:off x="850392" y="4142232"/>
+            <a:ext cx="2596896" cy="914400"/>
+          </a:xfrm>
+          <a:prstGeom prst="rect">
+            <a:avLst/>
+          </a:prstGeom>
+          <a:noFill/>
+          <a:ln/>
+        </p:spPr>
+        <p:txBody>
+          <a:bodyPr wrap="square" lIns="0" tIns="0" rIns="0" bIns="0" rtlCol="0" anchor="ctr"/>
+          <a:lstStyle/>
+          <a:p>
+            <a:pPr algn="ctr" indent="0" marL="0">
+              <a:lnSpc>
+                <a:spcPts val="1350"/>
+              </a:lnSpc>
+              <a:buNone/>
+            </a:pPr>
+            <a:r>
+              <a:rPr lang="en-US" sz="1050" dirty="0">
+                <a:solidFill>
+                  <a:srgbClr val="7A7A82"/>
+                </a:solidFill>
+                <a:latin typeface="Calibri" pitchFamily="34" charset="0"/>
+                <a:ea typeface="Calibri" pitchFamily="34" charset="-122"/>
+                <a:cs typeface="Calibri" pitchFamily="34" charset="-120"/>
+              </a:rPr>
+              <a:t>Müşterinin etkin katıldığı deneyim; amaç yeni bir şey öğrenmek.</a:t>
+            </a:r>
+            <a:endParaRPr lang="en-US" sz="1050" dirty="0"/>
+          </a:p>
+        </p:txBody>
+      </p:sp>
+      <p:sp>
+        <p:nvSpPr>
+          <p:cNvPr id="9" name="Text 7"/>
+          <p:cNvSpPr txBox="1"/>
+          <p:nvPr/>
+        </p:nvSpPr>
+        <p:spPr>
+          <a:xfrm>
+            <a:off x="850392" y="5138928"/>
+            <a:ext cx="2596896" cy="219456"/>
+          </a:xfrm>
+          <a:prstGeom prst="rect">
+            <a:avLst/>
+          </a:prstGeom>
+          <a:noFill/>
+          <a:ln/>
+        </p:spPr>
+        <p:txBody>
+          <a:bodyPr wrap="square" lIns="0" tIns="0" rIns="0" bIns="0" rtlCol="0" anchor="ctr"/>
+          <a:lstStyle/>
+          <a:p>
+            <a:pPr algn="ctr" indent="0" marL="0">
+              <a:buNone/>
+            </a:pPr>
+            <a:r>
+              <a:rPr lang="en-US" sz="800" b="1" spc="140" kern="0" dirty="0">
+                <a:solidFill>
+                  <a:srgbClr val="A6A6AC"/>
+                </a:solidFill>
+                <a:latin typeface="Calibri" pitchFamily="34" charset="0"/>
+                <a:ea typeface="Calibri" pitchFamily="34" charset="-122"/>
+                <a:cs typeface="Calibri" pitchFamily="34" charset="-120"/>
+              </a:rPr>
+              <a:t>MEKÂNSAL TALEP</a:t>
+            </a:r>
+            <a:endParaRPr lang="en-US" sz="800" dirty="0"/>
+          </a:p>
+        </p:txBody>
+      </p:sp>
+      <p:sp>
+        <p:nvSpPr>
+          <p:cNvPr id="10" name="Text 8"/>
+          <p:cNvSpPr txBox="1"/>
+          <p:nvPr/>
+        </p:nvSpPr>
+        <p:spPr>
+          <a:xfrm>
+            <a:off x="850392" y="5358384"/>
+            <a:ext cx="2596896" cy="502920"/>
+          </a:xfrm>
+          <a:prstGeom prst="rect">
+            <a:avLst/>
+          </a:prstGeom>
+          <a:noFill/>
+          <a:ln/>
+        </p:spPr>
+        <p:txBody>
+          <a:bodyPr wrap="square" lIns="0" tIns="0" rIns="0" bIns="0" rtlCol="0" anchor="ctr"/>
+          <a:lstStyle/>
+          <a:p>
+            <a:pPr algn="ctr" indent="0" marL="0">
+              <a:lnSpc>
+                <a:spcPts val="1250"/>
+              </a:lnSpc>
+              <a:buNone/>
+            </a:pPr>
+            <a:r>
+              <a:rPr lang="en-US" sz="1000" dirty="0">
+                <a:solidFill>
+                  <a:srgbClr val="8C3A2B"/>
+                </a:solidFill>
+                <a:latin typeface="Calibri" pitchFamily="34" charset="0"/>
+                <a:ea typeface="Calibri" pitchFamily="34" charset="-122"/>
+                <a:cs typeface="Calibri" pitchFamily="34" charset="-120"/>
+              </a:rPr>
+              <a:t>atölye masası · demo alanı · oturma düzeni</a:t>
+            </a:r>
+            <a:endParaRPr lang="en-US" sz="1000" dirty="0"/>
+          </a:p>
+        </p:txBody>
+      </p:sp>
+      <p:sp>
+        <p:nvSpPr>
+          <p:cNvPr id="11" name="Shape 9"/>
+          <p:cNvSpPr/>
+          <p:nvPr/>
+        </p:nvSpPr>
+        <p:spPr>
+          <a:xfrm>
+            <a:off x="2935224" y="3154680"/>
+            <a:ext cx="1216152" cy="0"/>
+          </a:xfrm>
+          <a:prstGeom prst="line">
+            <a:avLst/>
+          </a:prstGeom>
+          <a:noFill/>
+          <a:ln w="12700">
             <a:solidFill>
               <a:srgbClr val="C9C9CF"/>
             </a:solidFill>
@@ -6929,181 +7120,22 @@
       </p:sp>
       <p:sp>
         <p:nvSpPr>
-          <p:cNvPr id="7" name="Text 5"/>
-          <p:cNvSpPr txBox="1"/>
-          <p:nvPr/>
-        </p:nvSpPr>
-        <p:spPr>
-          <a:xfrm>
-            <a:off x="996696" y="2752344"/>
-            <a:ext cx="2048256" cy="365760"/>
-          </a:xfrm>
-          <a:prstGeom prst="rect">
-            <a:avLst/>
-          </a:prstGeom>
-          <a:noFill/>
-          <a:ln/>
-        </p:spPr>
-        <p:txBody>
-          <a:bodyPr wrap="square" lIns="0" tIns="0" rIns="0" bIns="0" rtlCol="0" anchor="ctr"/>
-          <a:lstStyle/>
-          <a:p>
-            <a:pPr indent="0" marL="0">
-              <a:buNone/>
-            </a:pPr>
-            <a:r>
-              <a:rPr lang="en-US" sz="1700" b="1" dirty="0">
-                <a:solidFill>
-                  <a:srgbClr val="16161A"/>
-                </a:solidFill>
-                <a:latin typeface="Cambria" pitchFamily="34" charset="0"/>
-                <a:ea typeface="Cambria" pitchFamily="34" charset="-122"/>
-                <a:cs typeface="Cambria" pitchFamily="34" charset="-120"/>
-              </a:rPr>
-              <a:t>Öğrenme</a:t>
-            </a:r>
-            <a:endParaRPr lang="en-US" sz="1700" dirty="0"/>
-          </a:p>
-        </p:txBody>
-      </p:sp>
-      <p:sp>
-        <p:nvSpPr>
-          <p:cNvPr id="8" name="Text 6"/>
-          <p:cNvSpPr txBox="1"/>
-          <p:nvPr/>
-        </p:nvSpPr>
-        <p:spPr>
-          <a:xfrm>
-            <a:off x="996696" y="3172968"/>
-            <a:ext cx="2048256" cy="960120"/>
-          </a:xfrm>
-          <a:prstGeom prst="rect">
-            <a:avLst/>
-          </a:prstGeom>
-          <a:noFill/>
-          <a:ln/>
-        </p:spPr>
-        <p:txBody>
-          <a:bodyPr wrap="square" lIns="0" tIns="0" rIns="0" bIns="0" rtlCol="0" anchor="ctr"/>
-          <a:lstStyle/>
-          <a:p>
-            <a:pPr indent="0" marL="0">
-              <a:lnSpc>
-                <a:spcPts val="1400"/>
-              </a:lnSpc>
-              <a:buNone/>
-            </a:pPr>
-            <a:r>
-              <a:rPr lang="en-US" sz="1100" dirty="0">
-                <a:solidFill>
-                  <a:srgbClr val="2B2B31"/>
-                </a:solidFill>
-                <a:latin typeface="Calibri" pitchFamily="34" charset="0"/>
-                <a:ea typeface="Calibri" pitchFamily="34" charset="-122"/>
-                <a:cs typeface="Calibri" pitchFamily="34" charset="-120"/>
-              </a:rPr>
-              <a:t>Müşterinin etkin katıldığı, yeni bir şey öğrendiği deneyim.</a:t>
-            </a:r>
-            <a:endParaRPr lang="en-US" sz="1100" dirty="0"/>
-          </a:p>
-        </p:txBody>
-      </p:sp>
-      <p:sp>
-        <p:nvSpPr>
-          <p:cNvPr id="9" name="Text 7"/>
-          <p:cNvSpPr txBox="1"/>
-          <p:nvPr/>
-        </p:nvSpPr>
-        <p:spPr>
-          <a:xfrm>
-            <a:off x="996696" y="4142232"/>
-            <a:ext cx="2048256" cy="219456"/>
-          </a:xfrm>
-          <a:prstGeom prst="rect">
-            <a:avLst/>
-          </a:prstGeom>
-          <a:noFill/>
-          <a:ln/>
-        </p:spPr>
-        <p:txBody>
-          <a:bodyPr wrap="square" lIns="0" tIns="0" rIns="0" bIns="0" rtlCol="0" anchor="ctr"/>
-          <a:lstStyle/>
-          <a:p>
-            <a:pPr indent="0" marL="0">
-              <a:buNone/>
-            </a:pPr>
-            <a:r>
-              <a:rPr lang="en-US" sz="800" b="1" spc="140" kern="0" dirty="0">
-                <a:solidFill>
-                  <a:srgbClr val="A6A6AC"/>
-                </a:solidFill>
-                <a:latin typeface="Calibri" pitchFamily="34" charset="0"/>
-                <a:ea typeface="Calibri" pitchFamily="34" charset="-122"/>
-                <a:cs typeface="Calibri" pitchFamily="34" charset="-120"/>
-              </a:rPr>
-              <a:t>MEKÂNSAL TALEP</a:t>
-            </a:r>
-            <a:endParaRPr lang="en-US" sz="800" dirty="0"/>
-          </a:p>
-        </p:txBody>
-      </p:sp>
-      <p:sp>
-        <p:nvSpPr>
-          <p:cNvPr id="10" name="Text 8"/>
-          <p:cNvSpPr txBox="1"/>
-          <p:nvPr/>
-        </p:nvSpPr>
-        <p:spPr>
-          <a:xfrm>
-            <a:off x="996696" y="4343400"/>
-            <a:ext cx="2048256" cy="365760"/>
-          </a:xfrm>
-          <a:prstGeom prst="rect">
-            <a:avLst/>
-          </a:prstGeom>
-          <a:noFill/>
-          <a:ln/>
-        </p:spPr>
-        <p:txBody>
-          <a:bodyPr wrap="square" lIns="0" tIns="0" rIns="0" bIns="0" rtlCol="0" anchor="ctr"/>
-          <a:lstStyle/>
-          <a:p>
-            <a:pPr indent="0" marL="0">
-              <a:lnSpc>
-                <a:spcPts val="1250"/>
-              </a:lnSpc>
-              <a:buNone/>
-            </a:pPr>
-            <a:r>
-              <a:rPr lang="en-US" sz="1000" dirty="0">
-                <a:solidFill>
-                  <a:srgbClr val="7A7A82"/>
-                </a:solidFill>
-                <a:latin typeface="Calibri" pitchFamily="34" charset="0"/>
-                <a:ea typeface="Calibri" pitchFamily="34" charset="-122"/>
-                <a:cs typeface="Calibri" pitchFamily="34" charset="-120"/>
-              </a:rPr>
-              <a:t>atölye masası · demo alanı · oturma</a:t>
-            </a:r>
-            <a:endParaRPr lang="en-US" sz="1000" dirty="0"/>
-          </a:p>
-        </p:txBody>
-      </p:sp>
-      <p:sp>
-        <p:nvSpPr>
-          <p:cNvPr id="11" name="Shape 9"/>
+          <p:cNvPr id="12" name="Shape 10"/>
           <p:cNvSpPr/>
           <p:nvPr/>
         </p:nvSpPr>
         <p:spPr>
           <a:xfrm>
-            <a:off x="3493008" y="2514600"/>
-            <a:ext cx="2487168" cy="2240280"/>
-          </a:xfrm>
-          <a:prstGeom prst="rect">
-            <a:avLst/>
-          </a:prstGeom>
-          <a:ln w="9525">
+            <a:off x="4151376" y="2368296"/>
+            <a:ext cx="1572768" cy="1572768"/>
+          </a:xfrm>
+          <a:prstGeom prst="ellipse">
+            <a:avLst/>
+          </a:prstGeom>
+          <a:solidFill>
+            <a:srgbClr val="FCFCFA"/>
+          </a:solidFill>
+          <a:ln w="12700">
             <a:solidFill>
               <a:srgbClr val="C9C9CF"/>
             </a:solidFill>
@@ -7113,72 +7145,176 @@
       </p:sp>
       <p:sp>
         <p:nvSpPr>
-          <p:cNvPr id="12" name="Text 10"/>
-          <p:cNvSpPr txBox="1"/>
-          <p:nvPr/>
-        </p:nvSpPr>
-        <p:spPr>
-          <a:xfrm>
-            <a:off x="3712464" y="2752344"/>
-            <a:ext cx="2048256" cy="365760"/>
-          </a:xfrm>
-          <a:prstGeom prst="rect">
-            <a:avLst/>
-          </a:prstGeom>
-          <a:noFill/>
-          <a:ln/>
-        </p:spPr>
-        <p:txBody>
-          <a:bodyPr wrap="square" lIns="0" tIns="0" rIns="0" bIns="0" rtlCol="0" anchor="ctr"/>
-          <a:lstStyle/>
-          <a:p>
-            <a:pPr indent="0" marL="0">
-              <a:buNone/>
-            </a:pPr>
-            <a:r>
-              <a:rPr lang="en-US" sz="1700" b="1" dirty="0">
+          <p:cNvPr id="13" name="Text 11"/>
+          <p:cNvSpPr txBox="1"/>
+          <p:nvPr/>
+        </p:nvSpPr>
+        <p:spPr>
+          <a:xfrm>
+            <a:off x="4151376" y="2743200"/>
+            <a:ext cx="1572768" cy="822960"/>
+          </a:xfrm>
+          <a:prstGeom prst="rect">
+            <a:avLst/>
+          </a:prstGeom>
+          <a:noFill/>
+          <a:ln/>
+        </p:spPr>
+        <p:txBody>
+          <a:bodyPr wrap="square" lIns="0" tIns="0" rIns="0" bIns="0" rtlCol="0" anchor="ctr"/>
+          <a:lstStyle/>
+          <a:p>
+            <a:pPr algn="ctr" indent="0" marL="0">
+              <a:lnSpc>
+                <a:spcPts val="1400"/>
+              </a:lnSpc>
+              <a:buNone/>
+            </a:pPr>
+            <a:r>
+              <a:rPr lang="en-US" sz="1100" b="1" dirty="0">
                 <a:solidFill>
                   <a:srgbClr val="16161A"/>
                 </a:solidFill>
-                <a:latin typeface="Cambria" pitchFamily="34" charset="0"/>
-                <a:ea typeface="Cambria" pitchFamily="34" charset="-122"/>
-                <a:cs typeface="Cambria" pitchFamily="34" charset="-120"/>
-              </a:rPr>
-              <a:t>Kişisel satış</a:t>
-            </a:r>
-            <a:endParaRPr lang="en-US" sz="1700" dirty="0"/>
-          </a:p>
-        </p:txBody>
-      </p:sp>
-      <p:sp>
-        <p:nvSpPr>
-          <p:cNvPr id="13" name="Text 11"/>
-          <p:cNvSpPr txBox="1"/>
-          <p:nvPr/>
-        </p:nvSpPr>
-        <p:spPr>
-          <a:xfrm>
-            <a:off x="3712464" y="3172968"/>
-            <a:ext cx="2048256" cy="960120"/>
-          </a:xfrm>
-          <a:prstGeom prst="rect">
-            <a:avLst/>
-          </a:prstGeom>
-          <a:noFill/>
-          <a:ln/>
-        </p:spPr>
-        <p:txBody>
-          <a:bodyPr wrap="square" lIns="0" tIns="0" rIns="0" bIns="0" rtlCol="0" anchor="ctr"/>
-          <a:lstStyle/>
-          <a:p>
-            <a:pPr indent="0" marL="0">
+                <a:latin typeface="Calibri" pitchFamily="34" charset="0"/>
+                <a:ea typeface="Calibri" pitchFamily="34" charset="-122"/>
+                <a:cs typeface="Calibri" pitchFamily="34" charset="-120"/>
+              </a:rPr>
+              <a:t>Kişisel</a:t>
+            </a:r>
+            <a:endParaRPr lang="en-US" sz="1100" dirty="0"/>
+          </a:p>
+          <a:p>
+            <a:pPr algn="ctr" indent="0" marL="0">
               <a:lnSpc>
                 <a:spcPts val="1400"/>
               </a:lnSpc>
               <a:buNone/>
             </a:pPr>
             <a:r>
-              <a:rPr lang="en-US" sz="1100" dirty="0">
+              <a:rPr lang="en-US" sz="1100" b="1" dirty="0">
+                <a:solidFill>
+                  <a:srgbClr val="16161A"/>
+                </a:solidFill>
+                <a:latin typeface="Calibri" pitchFamily="34" charset="0"/>
+                <a:ea typeface="Calibri" pitchFamily="34" charset="-122"/>
+                <a:cs typeface="Calibri" pitchFamily="34" charset="-120"/>
+              </a:rPr>
+              <a:t>satış</a:t>
+            </a:r>
+            <a:endParaRPr lang="en-US" sz="1100" dirty="0"/>
+          </a:p>
+        </p:txBody>
+      </p:sp>
+      <p:sp>
+        <p:nvSpPr>
+          <p:cNvPr id="14" name="Text 12"/>
+          <p:cNvSpPr txBox="1"/>
+          <p:nvPr/>
+        </p:nvSpPr>
+        <p:spPr>
+          <a:xfrm>
+            <a:off x="3639312" y="4142232"/>
+            <a:ext cx="2596896" cy="914400"/>
+          </a:xfrm>
+          <a:prstGeom prst="rect">
+            <a:avLst/>
+          </a:prstGeom>
+          <a:noFill/>
+          <a:ln/>
+        </p:spPr>
+        <p:txBody>
+          <a:bodyPr wrap="square" lIns="0" tIns="0" rIns="0" bIns="0" rtlCol="0" anchor="ctr"/>
+          <a:lstStyle/>
+          <a:p>
+            <a:pPr algn="ctr" indent="0" marL="0">
+              <a:lnSpc>
+                <a:spcPts val="1350"/>
+              </a:lnSpc>
+              <a:buNone/>
+            </a:pPr>
+            <a:r>
+              <a:rPr lang="en-US" sz="1050" dirty="0">
+                <a:solidFill>
+                  <a:srgbClr val="7A7A82"/>
+                </a:solidFill>
+                <a:latin typeface="Calibri" pitchFamily="34" charset="0"/>
+                <a:ea typeface="Calibri" pitchFamily="34" charset="-122"/>
+                <a:cs typeface="Calibri" pitchFamily="34" charset="-120"/>
+              </a:rPr>
+              <a:t>Satış görevlisinin rolü ürün gösterenden deneyim kurana dönüşür.</a:t>
+            </a:r>
+            <a:endParaRPr lang="en-US" sz="1050" dirty="0"/>
+          </a:p>
+        </p:txBody>
+      </p:sp>
+      <p:sp>
+        <p:nvSpPr>
+          <p:cNvPr id="15" name="Text 13"/>
+          <p:cNvSpPr txBox="1"/>
+          <p:nvPr/>
+        </p:nvSpPr>
+        <p:spPr>
+          <a:xfrm>
+            <a:off x="3639312" y="5138928"/>
+            <a:ext cx="2596896" cy="219456"/>
+          </a:xfrm>
+          <a:prstGeom prst="rect">
+            <a:avLst/>
+          </a:prstGeom>
+          <a:noFill/>
+          <a:ln/>
+        </p:spPr>
+        <p:txBody>
+          <a:bodyPr wrap="square" lIns="0" tIns="0" rIns="0" bIns="0" rtlCol="0" anchor="ctr"/>
+          <a:lstStyle/>
+          <a:p>
+            <a:pPr algn="ctr" indent="0" marL="0">
+              <a:buNone/>
+            </a:pPr>
+            <a:r>
+              <a:rPr lang="en-US" sz="800" b="1" spc="140" kern="0" dirty="0">
+                <a:solidFill>
+                  <a:srgbClr val="A6A6AC"/>
+                </a:solidFill>
+                <a:latin typeface="Calibri" pitchFamily="34" charset="0"/>
+                <a:ea typeface="Calibri" pitchFamily="34" charset="-122"/>
+                <a:cs typeface="Calibri" pitchFamily="34" charset="-120"/>
+              </a:rPr>
+              <a:t>MEKÂNSAL TALEP</a:t>
+            </a:r>
+            <a:endParaRPr lang="en-US" sz="800" dirty="0"/>
+          </a:p>
+        </p:txBody>
+      </p:sp>
+      <p:sp>
+        <p:nvSpPr>
+          <p:cNvPr id="16" name="Text 14"/>
+          <p:cNvSpPr txBox="1"/>
+          <p:nvPr/>
+        </p:nvSpPr>
+        <p:spPr>
+          <a:xfrm>
+            <a:off x="3639312" y="5358384"/>
+            <a:ext cx="2596896" cy="502920"/>
+          </a:xfrm>
+          <a:prstGeom prst="rect">
+            <a:avLst/>
+          </a:prstGeom>
+          <a:noFill/>
+          <a:ln/>
+        </p:spPr>
+        <p:txBody>
+          <a:bodyPr wrap="square" lIns="0" tIns="0" rIns="0" bIns="0" rtlCol="0" anchor="ctr"/>
+          <a:lstStyle/>
+          <a:p>
+            <a:pPr algn="ctr" indent="0" marL="0">
+              <a:lnSpc>
+                <a:spcPts val="1250"/>
+              </a:lnSpc>
+              <a:buNone/>
+            </a:pPr>
+            <a:r>
+              <a:rPr lang="en-US" sz="1000" dirty="0">
                 <a:solidFill>
                   <a:srgbClr val="2B2B31"/>
                 </a:solidFill>
@@ -7186,88 +7322,7 @@
                 <a:ea typeface="Calibri" pitchFamily="34" charset="-122"/>
                 <a:cs typeface="Calibri" pitchFamily="34" charset="-120"/>
               </a:rPr>
-              <a:t>Satış görevlisinin rolü ürün gösterenden deneyim kuranına dönüşür.</a:t>
-            </a:r>
-            <a:endParaRPr lang="en-US" sz="1100" dirty="0"/>
-          </a:p>
-        </p:txBody>
-      </p:sp>
-      <p:sp>
-        <p:nvSpPr>
-          <p:cNvPr id="14" name="Text 12"/>
-          <p:cNvSpPr txBox="1"/>
-          <p:nvPr/>
-        </p:nvSpPr>
-        <p:spPr>
-          <a:xfrm>
-            <a:off x="3712464" y="4142232"/>
-            <a:ext cx="2048256" cy="219456"/>
-          </a:xfrm>
-          <a:prstGeom prst="rect">
-            <a:avLst/>
-          </a:prstGeom>
-          <a:noFill/>
-          <a:ln/>
-        </p:spPr>
-        <p:txBody>
-          <a:bodyPr wrap="square" lIns="0" tIns="0" rIns="0" bIns="0" rtlCol="0" anchor="ctr"/>
-          <a:lstStyle/>
-          <a:p>
-            <a:pPr indent="0" marL="0">
-              <a:buNone/>
-            </a:pPr>
-            <a:r>
-              <a:rPr lang="en-US" sz="800" b="1" spc="140" kern="0" dirty="0">
-                <a:solidFill>
-                  <a:srgbClr val="A6A6AC"/>
-                </a:solidFill>
-                <a:latin typeface="Calibri" pitchFamily="34" charset="0"/>
-                <a:ea typeface="Calibri" pitchFamily="34" charset="-122"/>
-                <a:cs typeface="Calibri" pitchFamily="34" charset="-120"/>
-              </a:rPr>
-              <a:t>MEKÂNSAL TALEP</a:t>
-            </a:r>
-            <a:endParaRPr lang="en-US" sz="800" dirty="0"/>
-          </a:p>
-        </p:txBody>
-      </p:sp>
-      <p:sp>
-        <p:nvSpPr>
-          <p:cNvPr id="15" name="Text 13"/>
-          <p:cNvSpPr txBox="1"/>
-          <p:nvPr/>
-        </p:nvSpPr>
-        <p:spPr>
-          <a:xfrm>
-            <a:off x="3712464" y="4343400"/>
-            <a:ext cx="2048256" cy="365760"/>
-          </a:xfrm>
-          <a:prstGeom prst="rect">
-            <a:avLst/>
-          </a:prstGeom>
-          <a:noFill/>
-          <a:ln/>
-        </p:spPr>
-        <p:txBody>
-          <a:bodyPr wrap="square" lIns="0" tIns="0" rIns="0" bIns="0" rtlCol="0" anchor="ctr"/>
-          <a:lstStyle/>
-          <a:p>
-            <a:pPr indent="0" marL="0">
-              <a:lnSpc>
-                <a:spcPts val="1250"/>
-              </a:lnSpc>
-              <a:buNone/>
-            </a:pPr>
-            <a:r>
-              <a:rPr lang="en-US" sz="1000" dirty="0">
-                <a:solidFill>
-                  <a:srgbClr val="7A7A82"/>
-                </a:solidFill>
-                <a:latin typeface="Calibri" pitchFamily="34" charset="0"/>
-                <a:ea typeface="Calibri" pitchFamily="34" charset="-122"/>
-                <a:cs typeface="Calibri" pitchFamily="34" charset="-120"/>
-              </a:rPr>
-              <a:t>danışma noktası · ölçü alma · birebir tezgâh</a:t>
+              <a:t>danışma noktası · birebir tezgâh · ölçü alma</a:t>
             </a:r>
             <a:endParaRPr lang="en-US" sz="1000" dirty="0"/>
           </a:p>
@@ -7275,19 +7330,20 @@
       </p:sp>
       <p:sp>
         <p:nvSpPr>
-          <p:cNvPr id="16" name="Shape 14"/>
+          <p:cNvPr id="17" name="Shape 15"/>
           <p:cNvSpPr/>
           <p:nvPr/>
         </p:nvSpPr>
         <p:spPr>
           <a:xfrm>
-            <a:off x="6208776" y="2514600"/>
-            <a:ext cx="2487168" cy="2240280"/>
-          </a:xfrm>
-          <a:prstGeom prst="rect">
-            <a:avLst/>
-          </a:prstGeom>
-          <a:ln w="9525">
+            <a:off x="5724144" y="3154680"/>
+            <a:ext cx="1216152" cy="0"/>
+          </a:xfrm>
+          <a:prstGeom prst="line">
+            <a:avLst/>
+          </a:prstGeom>
+          <a:noFill/>
+          <a:ln w="12700">
             <a:solidFill>
               <a:srgbClr val="C9C9CF"/>
             </a:solidFill>
@@ -7297,434 +7353,486 @@
       </p:sp>
       <p:sp>
         <p:nvSpPr>
-          <p:cNvPr id="17" name="Text 15"/>
-          <p:cNvSpPr txBox="1"/>
-          <p:nvPr/>
-        </p:nvSpPr>
-        <p:spPr>
-          <a:xfrm>
-            <a:off x="6428232" y="2752344"/>
-            <a:ext cx="2048256" cy="365760"/>
-          </a:xfrm>
-          <a:prstGeom prst="rect">
-            <a:avLst/>
-          </a:prstGeom>
-          <a:noFill/>
-          <a:ln/>
-        </p:spPr>
-        <p:txBody>
-          <a:bodyPr wrap="square" lIns="0" tIns="0" rIns="0" bIns="0" rtlCol="0" anchor="ctr"/>
-          <a:lstStyle/>
-          <a:p>
-            <a:pPr indent="0" marL="0">
-              <a:buNone/>
-            </a:pPr>
-            <a:r>
-              <a:rPr lang="en-US" sz="1700" b="1" dirty="0">
+          <p:cNvPr id="18" name="Shape 16"/>
+          <p:cNvSpPr/>
+          <p:nvPr/>
+        </p:nvSpPr>
+        <p:spPr>
+          <a:xfrm>
+            <a:off x="6940296" y="2368296"/>
+            <a:ext cx="1572768" cy="1572768"/>
+          </a:xfrm>
+          <a:prstGeom prst="ellipse">
+            <a:avLst/>
+          </a:prstGeom>
+          <a:solidFill>
+            <a:srgbClr val="FCFCFA"/>
+          </a:solidFill>
+          <a:ln w="12700">
+            <a:solidFill>
+              <a:srgbClr val="C9C9CF"/>
+            </a:solidFill>
+            <a:prstDash val="solid"/>
+          </a:ln>
+        </p:spPr>
+      </p:sp>
+      <p:sp>
+        <p:nvSpPr>
+          <p:cNvPr id="19" name="Text 17"/>
+          <p:cNvSpPr txBox="1"/>
+          <p:nvPr/>
+        </p:nvSpPr>
+        <p:spPr>
+          <a:xfrm>
+            <a:off x="6940296" y="2743200"/>
+            <a:ext cx="1572768" cy="822960"/>
+          </a:xfrm>
+          <a:prstGeom prst="rect">
+            <a:avLst/>
+          </a:prstGeom>
+          <a:noFill/>
+          <a:ln/>
+        </p:spPr>
+        <p:txBody>
+          <a:bodyPr wrap="square" lIns="0" tIns="0" rIns="0" bIns="0" rtlCol="0" anchor="ctr"/>
+          <a:lstStyle/>
+          <a:p>
+            <a:pPr algn="ctr" indent="0" marL="0">
+              <a:lnSpc>
+                <a:spcPts val="1400"/>
+              </a:lnSpc>
+              <a:buNone/>
+            </a:pPr>
+            <a:r>
+              <a:rPr lang="en-US" sz="1100" b="1" dirty="0">
                 <a:solidFill>
                   <a:srgbClr val="16161A"/>
+                </a:solidFill>
+                <a:latin typeface="Calibri" pitchFamily="34" charset="0"/>
+                <a:ea typeface="Calibri" pitchFamily="34" charset="-122"/>
+                <a:cs typeface="Calibri" pitchFamily="34" charset="-120"/>
+              </a:rPr>
+              <a:t>Çok</a:t>
+            </a:r>
+            <a:endParaRPr lang="en-US" sz="1100" dirty="0"/>
+          </a:p>
+          <a:p>
+            <a:pPr algn="ctr" indent="0" marL="0">
+              <a:lnSpc>
+                <a:spcPts val="1400"/>
+              </a:lnSpc>
+              <a:buNone/>
+            </a:pPr>
+            <a:r>
+              <a:rPr lang="en-US" sz="1100" b="1" dirty="0">
+                <a:solidFill>
+                  <a:srgbClr val="16161A"/>
+                </a:solidFill>
+                <a:latin typeface="Calibri" pitchFamily="34" charset="0"/>
+                <a:ea typeface="Calibri" pitchFamily="34" charset="-122"/>
+                <a:cs typeface="Calibri" pitchFamily="34" charset="-120"/>
+              </a:rPr>
+              <a:t>kanallılık</a:t>
+            </a:r>
+            <a:endParaRPr lang="en-US" sz="1100" dirty="0"/>
+          </a:p>
+        </p:txBody>
+      </p:sp>
+      <p:sp>
+        <p:nvSpPr>
+          <p:cNvPr id="20" name="Text 18"/>
+          <p:cNvSpPr txBox="1"/>
+          <p:nvPr/>
+        </p:nvSpPr>
+        <p:spPr>
+          <a:xfrm>
+            <a:off x="6428232" y="4142232"/>
+            <a:ext cx="2596896" cy="914400"/>
+          </a:xfrm>
+          <a:prstGeom prst="rect">
+            <a:avLst/>
+          </a:prstGeom>
+          <a:noFill/>
+          <a:ln/>
+        </p:spPr>
+        <p:txBody>
+          <a:bodyPr wrap="square" lIns="0" tIns="0" rIns="0" bIns="0" rtlCol="0" anchor="ctr"/>
+          <a:lstStyle/>
+          <a:p>
+            <a:pPr algn="ctr" indent="0" marL="0">
+              <a:lnSpc>
+                <a:spcPts val="1350"/>
+              </a:lnSpc>
+              <a:buNone/>
+            </a:pPr>
+            <a:r>
+              <a:rPr lang="en-US" sz="1050" dirty="0">
+                <a:solidFill>
+                  <a:srgbClr val="7A7A82"/>
+                </a:solidFill>
+                <a:latin typeface="Calibri" pitchFamily="34" charset="0"/>
+                <a:ea typeface="Calibri" pitchFamily="34" charset="-122"/>
+                <a:cs typeface="Calibri" pitchFamily="34" charset="-120"/>
+              </a:rPr>
+              <a:t>Müşteri birden çok kanaldan geliyor; mağaza bunları buluşturmalı.</a:t>
+            </a:r>
+            <a:endParaRPr lang="en-US" sz="1050" dirty="0"/>
+          </a:p>
+        </p:txBody>
+      </p:sp>
+      <p:sp>
+        <p:nvSpPr>
+          <p:cNvPr id="21" name="Text 19"/>
+          <p:cNvSpPr txBox="1"/>
+          <p:nvPr/>
+        </p:nvSpPr>
+        <p:spPr>
+          <a:xfrm>
+            <a:off x="6428232" y="5138928"/>
+            <a:ext cx="2596896" cy="219456"/>
+          </a:xfrm>
+          <a:prstGeom prst="rect">
+            <a:avLst/>
+          </a:prstGeom>
+          <a:noFill/>
+          <a:ln/>
+        </p:spPr>
+        <p:txBody>
+          <a:bodyPr wrap="square" lIns="0" tIns="0" rIns="0" bIns="0" rtlCol="0" anchor="ctr"/>
+          <a:lstStyle/>
+          <a:p>
+            <a:pPr algn="ctr" indent="0" marL="0">
+              <a:buNone/>
+            </a:pPr>
+            <a:r>
+              <a:rPr lang="en-US" sz="800" b="1" spc="140" kern="0" dirty="0">
+                <a:solidFill>
+                  <a:srgbClr val="A6A6AC"/>
+                </a:solidFill>
+                <a:latin typeface="Calibri" pitchFamily="34" charset="0"/>
+                <a:ea typeface="Calibri" pitchFamily="34" charset="-122"/>
+                <a:cs typeface="Calibri" pitchFamily="34" charset="-120"/>
+              </a:rPr>
+              <a:t>MEKÂNSAL TALEP</a:t>
+            </a:r>
+            <a:endParaRPr lang="en-US" sz="800" dirty="0"/>
+          </a:p>
+        </p:txBody>
+      </p:sp>
+      <p:sp>
+        <p:nvSpPr>
+          <p:cNvPr id="22" name="Text 20"/>
+          <p:cNvSpPr txBox="1"/>
+          <p:nvPr/>
+        </p:nvSpPr>
+        <p:spPr>
+          <a:xfrm>
+            <a:off x="6428232" y="5358384"/>
+            <a:ext cx="2596896" cy="502920"/>
+          </a:xfrm>
+          <a:prstGeom prst="rect">
+            <a:avLst/>
+          </a:prstGeom>
+          <a:noFill/>
+          <a:ln/>
+        </p:spPr>
+        <p:txBody>
+          <a:bodyPr wrap="square" lIns="0" tIns="0" rIns="0" bIns="0" rtlCol="0" anchor="ctr"/>
+          <a:lstStyle/>
+          <a:p>
+            <a:pPr algn="ctr" indent="0" marL="0">
+              <a:lnSpc>
+                <a:spcPts val="1250"/>
+              </a:lnSpc>
+              <a:buNone/>
+            </a:pPr>
+            <a:r>
+              <a:rPr lang="en-US" sz="1000" dirty="0">
+                <a:solidFill>
+                  <a:srgbClr val="2B2B31"/>
+                </a:solidFill>
+                <a:latin typeface="Calibri" pitchFamily="34" charset="0"/>
+                <a:ea typeface="Calibri" pitchFamily="34" charset="-122"/>
+                <a:cs typeface="Calibri" pitchFamily="34" charset="-120"/>
+              </a:rPr>
+              <a:t>stok sorgu · online sipariş teslimi · iade noktası</a:t>
+            </a:r>
+            <a:endParaRPr lang="en-US" sz="1000" dirty="0"/>
+          </a:p>
+        </p:txBody>
+      </p:sp>
+      <p:sp>
+        <p:nvSpPr>
+          <p:cNvPr id="23" name="Shape 21"/>
+          <p:cNvSpPr/>
+          <p:nvPr/>
+        </p:nvSpPr>
+        <p:spPr>
+          <a:xfrm>
+            <a:off x="8513064" y="3154680"/>
+            <a:ext cx="1216152" cy="0"/>
+          </a:xfrm>
+          <a:prstGeom prst="line">
+            <a:avLst/>
+          </a:prstGeom>
+          <a:noFill/>
+          <a:ln w="12700">
+            <a:solidFill>
+              <a:srgbClr val="C9C9CF"/>
+            </a:solidFill>
+            <a:prstDash val="solid"/>
+          </a:ln>
+        </p:spPr>
+      </p:sp>
+      <p:sp>
+        <p:nvSpPr>
+          <p:cNvPr id="24" name="Shape 22"/>
+          <p:cNvSpPr/>
+          <p:nvPr/>
+        </p:nvSpPr>
+        <p:spPr>
+          <a:xfrm>
+            <a:off x="9729216" y="2368296"/>
+            <a:ext cx="1572768" cy="1572768"/>
+          </a:xfrm>
+          <a:prstGeom prst="ellipse">
+            <a:avLst/>
+          </a:prstGeom>
+          <a:solidFill>
+            <a:srgbClr val="FCFCFA"/>
+          </a:solidFill>
+          <a:ln w="12700">
+            <a:solidFill>
+              <a:srgbClr val="C9C9CF"/>
+            </a:solidFill>
+            <a:prstDash val="solid"/>
+          </a:ln>
+        </p:spPr>
+      </p:sp>
+      <p:sp>
+        <p:nvSpPr>
+          <p:cNvPr id="25" name="Text 23"/>
+          <p:cNvSpPr txBox="1"/>
+          <p:nvPr/>
+        </p:nvSpPr>
+        <p:spPr>
+          <a:xfrm>
+            <a:off x="9729216" y="2743200"/>
+            <a:ext cx="1572768" cy="822960"/>
+          </a:xfrm>
+          <a:prstGeom prst="rect">
+            <a:avLst/>
+          </a:prstGeom>
+          <a:noFill/>
+          <a:ln/>
+        </p:spPr>
+        <p:txBody>
+          <a:bodyPr wrap="square" lIns="0" tIns="0" rIns="0" bIns="0" rtlCol="0" anchor="ctr"/>
+          <a:lstStyle/>
+          <a:p>
+            <a:pPr algn="ctr" indent="0" marL="0">
+              <a:lnSpc>
+                <a:spcPts val="1400"/>
+              </a:lnSpc>
+              <a:buNone/>
+            </a:pPr>
+            <a:r>
+              <a:rPr lang="en-US" sz="1100" b="1" dirty="0">
+                <a:solidFill>
+                  <a:srgbClr val="16161A"/>
+                </a:solidFill>
+                <a:latin typeface="Calibri" pitchFamily="34" charset="0"/>
+                <a:ea typeface="Calibri" pitchFamily="34" charset="-122"/>
+                <a:cs typeface="Calibri" pitchFamily="34" charset="-120"/>
+              </a:rPr>
+              <a:t>Hazine</a:t>
+            </a:r>
+            <a:endParaRPr lang="en-US" sz="1100" dirty="0"/>
+          </a:p>
+          <a:p>
+            <a:pPr algn="ctr" indent="0" marL="0">
+              <a:lnSpc>
+                <a:spcPts val="1400"/>
+              </a:lnSpc>
+              <a:buNone/>
+            </a:pPr>
+            <a:r>
+              <a:rPr lang="en-US" sz="1100" b="1" dirty="0">
+                <a:solidFill>
+                  <a:srgbClr val="16161A"/>
+                </a:solidFill>
+                <a:latin typeface="Calibri" pitchFamily="34" charset="0"/>
+                <a:ea typeface="Calibri" pitchFamily="34" charset="-122"/>
+                <a:cs typeface="Calibri" pitchFamily="34" charset="-120"/>
+              </a:rPr>
+              <a:t>avı</a:t>
+            </a:r>
+            <a:endParaRPr lang="en-US" sz="1100" dirty="0"/>
+          </a:p>
+        </p:txBody>
+      </p:sp>
+      <p:sp>
+        <p:nvSpPr>
+          <p:cNvPr id="26" name="Text 24"/>
+          <p:cNvSpPr txBox="1"/>
+          <p:nvPr/>
+        </p:nvSpPr>
+        <p:spPr>
+          <a:xfrm>
+            <a:off x="9217152" y="4142232"/>
+            <a:ext cx="2596896" cy="914400"/>
+          </a:xfrm>
+          <a:prstGeom prst="rect">
+            <a:avLst/>
+          </a:prstGeom>
+          <a:noFill/>
+          <a:ln/>
+        </p:spPr>
+        <p:txBody>
+          <a:bodyPr wrap="square" lIns="0" tIns="0" rIns="0" bIns="0" rtlCol="0" anchor="ctr"/>
+          <a:lstStyle/>
+          <a:p>
+            <a:pPr algn="ctr" indent="0" marL="0">
+              <a:lnSpc>
+                <a:spcPts val="1350"/>
+              </a:lnSpc>
+              <a:buNone/>
+            </a:pPr>
+            <a:r>
+              <a:rPr lang="en-US" sz="1050" dirty="0">
+                <a:solidFill>
+                  <a:srgbClr val="7A7A82"/>
+                </a:solidFill>
+                <a:latin typeface="Calibri" pitchFamily="34" charset="0"/>
+                <a:ea typeface="Calibri" pitchFamily="34" charset="-122"/>
+                <a:cs typeface="Calibri" pitchFamily="34" charset="-120"/>
+              </a:rPr>
+              <a:t>Sınırlı sürede bulunan ürünlerin yarattığı heyecan; hızlı ürün değişimi.</a:t>
+            </a:r>
+            <a:endParaRPr lang="en-US" sz="1050" dirty="0"/>
+          </a:p>
+        </p:txBody>
+      </p:sp>
+      <p:sp>
+        <p:nvSpPr>
+          <p:cNvPr id="27" name="Text 25"/>
+          <p:cNvSpPr txBox="1"/>
+          <p:nvPr/>
+        </p:nvSpPr>
+        <p:spPr>
+          <a:xfrm>
+            <a:off x="9217152" y="5138928"/>
+            <a:ext cx="2596896" cy="219456"/>
+          </a:xfrm>
+          <a:prstGeom prst="rect">
+            <a:avLst/>
+          </a:prstGeom>
+          <a:noFill/>
+          <a:ln/>
+        </p:spPr>
+        <p:txBody>
+          <a:bodyPr wrap="square" lIns="0" tIns="0" rIns="0" bIns="0" rtlCol="0" anchor="ctr"/>
+          <a:lstStyle/>
+          <a:p>
+            <a:pPr algn="ctr" indent="0" marL="0">
+              <a:buNone/>
+            </a:pPr>
+            <a:r>
+              <a:rPr lang="en-US" sz="800" b="1" spc="140" kern="0" dirty="0">
+                <a:solidFill>
+                  <a:srgbClr val="A6A6AC"/>
+                </a:solidFill>
+                <a:latin typeface="Calibri" pitchFamily="34" charset="0"/>
+                <a:ea typeface="Calibri" pitchFamily="34" charset="-122"/>
+                <a:cs typeface="Calibri" pitchFamily="34" charset="-120"/>
+              </a:rPr>
+              <a:t>MEKÂNSAL TALEP</a:t>
+            </a:r>
+            <a:endParaRPr lang="en-US" sz="800" dirty="0"/>
+          </a:p>
+        </p:txBody>
+      </p:sp>
+      <p:sp>
+        <p:nvSpPr>
+          <p:cNvPr id="28" name="Text 26"/>
+          <p:cNvSpPr txBox="1"/>
+          <p:nvPr/>
+        </p:nvSpPr>
+        <p:spPr>
+          <a:xfrm>
+            <a:off x="9217152" y="5358384"/>
+            <a:ext cx="2596896" cy="502920"/>
+          </a:xfrm>
+          <a:prstGeom prst="rect">
+            <a:avLst/>
+          </a:prstGeom>
+          <a:noFill/>
+          <a:ln/>
+        </p:spPr>
+        <p:txBody>
+          <a:bodyPr wrap="square" lIns="0" tIns="0" rIns="0" bIns="0" rtlCol="0" anchor="ctr"/>
+          <a:lstStyle/>
+          <a:p>
+            <a:pPr algn="ctr" indent="0" marL="0">
+              <a:lnSpc>
+                <a:spcPts val="1250"/>
+              </a:lnSpc>
+              <a:buNone/>
+            </a:pPr>
+            <a:r>
+              <a:rPr lang="en-US" sz="1000" dirty="0">
+                <a:solidFill>
+                  <a:srgbClr val="2B2B31"/>
+                </a:solidFill>
+                <a:latin typeface="Calibri" pitchFamily="34" charset="0"/>
+                <a:ea typeface="Calibri" pitchFamily="34" charset="-122"/>
+                <a:cs typeface="Calibri" pitchFamily="34" charset="-120"/>
+              </a:rPr>
+              <a:t>esnek teşhir · kampanya alanı · değişebilir düzen</a:t>
+            </a:r>
+            <a:endParaRPr lang="en-US" sz="1000" dirty="0"/>
+          </a:p>
+        </p:txBody>
+      </p:sp>
+      <p:sp>
+        <p:nvSpPr>
+          <p:cNvPr id="29" name="Text 27"/>
+          <p:cNvSpPr txBox="1"/>
+          <p:nvPr/>
+        </p:nvSpPr>
+        <p:spPr>
+          <a:xfrm>
+            <a:off x="777240" y="5961888"/>
+            <a:ext cx="9966960" cy="365760"/>
+          </a:xfrm>
+          <a:prstGeom prst="rect">
+            <a:avLst/>
+          </a:prstGeom>
+          <a:noFill/>
+          <a:ln/>
+        </p:spPr>
+        <p:txBody>
+          <a:bodyPr wrap="square" lIns="0" tIns="0" rIns="0" bIns="0" rtlCol="0" anchor="ctr"/>
+          <a:lstStyle/>
+          <a:p>
+            <a:pPr algn="l" indent="0" marL="0">
+              <a:lnSpc>
+                <a:spcPts val="1200"/>
+              </a:lnSpc>
+              <a:buNone/>
+            </a:pPr>
+            <a:r>
+              <a:rPr lang="en-US" sz="1250" i="1" dirty="0">
+                <a:solidFill>
+                  <a:srgbClr val="8C3A2B"/>
                 </a:solidFill>
                 <a:latin typeface="Cambria" pitchFamily="34" charset="0"/>
                 <a:ea typeface="Cambria" pitchFamily="34" charset="-122"/>
                 <a:cs typeface="Cambria" pitchFamily="34" charset="-120"/>
               </a:rPr>
-              <a:t>Çok kanallılık</a:t>
-            </a:r>
-            <a:endParaRPr lang="en-US" sz="1700" dirty="0"/>
-          </a:p>
-        </p:txBody>
-      </p:sp>
-      <p:sp>
-        <p:nvSpPr>
-          <p:cNvPr id="18" name="Text 16"/>
-          <p:cNvSpPr txBox="1"/>
-          <p:nvPr/>
-        </p:nvSpPr>
-        <p:spPr>
-          <a:xfrm>
-            <a:off x="6428232" y="3172968"/>
-            <a:ext cx="2048256" cy="960120"/>
-          </a:xfrm>
-          <a:prstGeom prst="rect">
-            <a:avLst/>
-          </a:prstGeom>
-          <a:noFill/>
-          <a:ln/>
-        </p:spPr>
-        <p:txBody>
-          <a:bodyPr wrap="square" lIns="0" tIns="0" rIns="0" bIns="0" rtlCol="0" anchor="ctr"/>
-          <a:lstStyle/>
-          <a:p>
-            <a:pPr indent="0" marL="0">
-              <a:lnSpc>
-                <a:spcPts val="1400"/>
-              </a:lnSpc>
-              <a:buNone/>
-            </a:pPr>
-            <a:r>
-              <a:rPr lang="en-US" sz="1100" dirty="0">
-                <a:solidFill>
-                  <a:srgbClr val="2B2B31"/>
-                </a:solidFill>
-                <a:latin typeface="Calibri" pitchFamily="34" charset="0"/>
-                <a:ea typeface="Calibri" pitchFamily="34" charset="-122"/>
-                <a:cs typeface="Calibri" pitchFamily="34" charset="-120"/>
-              </a:rPr>
-              <a:t>Müşteri birden çok kanaldan geliyor; mağaza bunları buluşturmalı.</a:t>
-            </a:r>
-            <a:endParaRPr lang="en-US" sz="1100" dirty="0"/>
-          </a:p>
-        </p:txBody>
-      </p:sp>
-      <p:sp>
-        <p:nvSpPr>
-          <p:cNvPr id="19" name="Text 17"/>
-          <p:cNvSpPr txBox="1"/>
-          <p:nvPr/>
-        </p:nvSpPr>
-        <p:spPr>
-          <a:xfrm>
-            <a:off x="6428232" y="4142232"/>
-            <a:ext cx="2048256" cy="219456"/>
-          </a:xfrm>
-          <a:prstGeom prst="rect">
-            <a:avLst/>
-          </a:prstGeom>
-          <a:noFill/>
-          <a:ln/>
-        </p:spPr>
-        <p:txBody>
-          <a:bodyPr wrap="square" lIns="0" tIns="0" rIns="0" bIns="0" rtlCol="0" anchor="ctr"/>
-          <a:lstStyle/>
-          <a:p>
-            <a:pPr indent="0" marL="0">
-              <a:buNone/>
-            </a:pPr>
-            <a:r>
-              <a:rPr lang="en-US" sz="800" b="1" spc="140" kern="0" dirty="0">
-                <a:solidFill>
-                  <a:srgbClr val="A6A6AC"/>
-                </a:solidFill>
-                <a:latin typeface="Calibri" pitchFamily="34" charset="0"/>
-                <a:ea typeface="Calibri" pitchFamily="34" charset="-122"/>
-                <a:cs typeface="Calibri" pitchFamily="34" charset="-120"/>
-              </a:rPr>
-              <a:t>MEKÂNSAL TALEP</a:t>
-            </a:r>
-            <a:endParaRPr lang="en-US" sz="800" dirty="0"/>
-          </a:p>
-        </p:txBody>
-      </p:sp>
-      <p:sp>
-        <p:nvSpPr>
-          <p:cNvPr id="20" name="Text 18"/>
-          <p:cNvSpPr txBox="1"/>
-          <p:nvPr/>
-        </p:nvSpPr>
-        <p:spPr>
-          <a:xfrm>
-            <a:off x="6428232" y="4343400"/>
-            <a:ext cx="2048256" cy="365760"/>
-          </a:xfrm>
-          <a:prstGeom prst="rect">
-            <a:avLst/>
-          </a:prstGeom>
-          <a:noFill/>
-          <a:ln/>
-        </p:spPr>
-        <p:txBody>
-          <a:bodyPr wrap="square" lIns="0" tIns="0" rIns="0" bIns="0" rtlCol="0" anchor="ctr"/>
-          <a:lstStyle/>
-          <a:p>
-            <a:pPr indent="0" marL="0">
-              <a:lnSpc>
-                <a:spcPts val="1250"/>
-              </a:lnSpc>
-              <a:buNone/>
-            </a:pPr>
-            <a:r>
-              <a:rPr lang="en-US" sz="1000" dirty="0">
-                <a:solidFill>
-                  <a:srgbClr val="7A7A82"/>
-                </a:solidFill>
-                <a:latin typeface="Calibri" pitchFamily="34" charset="0"/>
-                <a:ea typeface="Calibri" pitchFamily="34" charset="-122"/>
-                <a:cs typeface="Calibri" pitchFamily="34" charset="-120"/>
-              </a:rPr>
-              <a:t>stok sorgu · online sipariş teslim · iade</a:t>
-            </a:r>
-            <a:endParaRPr lang="en-US" sz="1000" dirty="0"/>
-          </a:p>
-        </p:txBody>
-      </p:sp>
-      <p:sp>
-        <p:nvSpPr>
-          <p:cNvPr id="21" name="Shape 19"/>
-          <p:cNvSpPr/>
-          <p:nvPr/>
-        </p:nvSpPr>
-        <p:spPr>
-          <a:xfrm>
-            <a:off x="8924544" y="2514600"/>
-            <a:ext cx="2487168" cy="2240280"/>
-          </a:xfrm>
-          <a:prstGeom prst="rect">
-            <a:avLst/>
-          </a:prstGeom>
-          <a:solidFill>
-            <a:srgbClr val="F6EAE6"/>
-          </a:solidFill>
-          <a:ln w="15875">
-            <a:solidFill>
-              <a:srgbClr val="8C3A2B"/>
-            </a:solidFill>
-            <a:prstDash val="solid"/>
-          </a:ln>
-        </p:spPr>
-      </p:sp>
-      <p:sp>
-        <p:nvSpPr>
-          <p:cNvPr id="22" name="Text 20"/>
-          <p:cNvSpPr txBox="1"/>
-          <p:nvPr/>
-        </p:nvSpPr>
-        <p:spPr>
-          <a:xfrm>
-            <a:off x="9144000" y="2752344"/>
-            <a:ext cx="2048256" cy="365760"/>
-          </a:xfrm>
-          <a:prstGeom prst="rect">
-            <a:avLst/>
-          </a:prstGeom>
-          <a:noFill/>
-          <a:ln/>
-        </p:spPr>
-        <p:txBody>
-          <a:bodyPr wrap="square" lIns="0" tIns="0" rIns="0" bIns="0" rtlCol="0" anchor="ctr"/>
-          <a:lstStyle/>
-          <a:p>
-            <a:pPr indent="0" marL="0">
-              <a:buNone/>
-            </a:pPr>
-            <a:r>
-              <a:rPr lang="en-US" sz="1700" b="1" dirty="0">
-                <a:solidFill>
-                  <a:srgbClr val="8C3A2B"/>
-                </a:solidFill>
-                <a:latin typeface="Cambria" pitchFamily="34" charset="0"/>
-                <a:ea typeface="Cambria" pitchFamily="34" charset="-122"/>
-                <a:cs typeface="Cambria" pitchFamily="34" charset="-120"/>
-              </a:rPr>
-              <a:t>Hazine avı</a:t>
-            </a:r>
-            <a:endParaRPr lang="en-US" sz="1700" dirty="0"/>
-          </a:p>
-        </p:txBody>
-      </p:sp>
-      <p:sp>
-        <p:nvSpPr>
-          <p:cNvPr id="23" name="Text 21"/>
-          <p:cNvSpPr txBox="1"/>
-          <p:nvPr/>
-        </p:nvSpPr>
-        <p:spPr>
-          <a:xfrm>
-            <a:off x="9144000" y="3172968"/>
-            <a:ext cx="2048256" cy="960120"/>
-          </a:xfrm>
-          <a:prstGeom prst="rect">
-            <a:avLst/>
-          </a:prstGeom>
-          <a:noFill/>
-          <a:ln/>
-        </p:spPr>
-        <p:txBody>
-          <a:bodyPr wrap="square" lIns="0" tIns="0" rIns="0" bIns="0" rtlCol="0" anchor="ctr"/>
-          <a:lstStyle/>
-          <a:p>
-            <a:pPr indent="0" marL="0">
-              <a:lnSpc>
-                <a:spcPts val="1400"/>
-              </a:lnSpc>
-              <a:buNone/>
-            </a:pPr>
-            <a:r>
-              <a:rPr lang="en-US" sz="1100" dirty="0">
-                <a:solidFill>
-                  <a:srgbClr val="2B2B31"/>
-                </a:solidFill>
-                <a:latin typeface="Calibri" pitchFamily="34" charset="0"/>
-                <a:ea typeface="Calibri" pitchFamily="34" charset="-122"/>
-                <a:cs typeface="Calibri" pitchFamily="34" charset="-120"/>
-              </a:rPr>
-              <a:t>Sınırlı sürede bulunan ürünlerin yarattığı heyecan; hızlı ürün değişimi.</a:t>
-            </a:r>
-            <a:endParaRPr lang="en-US" sz="1100" dirty="0"/>
-          </a:p>
-        </p:txBody>
-      </p:sp>
-      <p:sp>
-        <p:nvSpPr>
-          <p:cNvPr id="24" name="Text 22"/>
-          <p:cNvSpPr txBox="1"/>
-          <p:nvPr/>
-        </p:nvSpPr>
-        <p:spPr>
-          <a:xfrm>
-            <a:off x="9144000" y="4142232"/>
-            <a:ext cx="2048256" cy="219456"/>
-          </a:xfrm>
-          <a:prstGeom prst="rect">
-            <a:avLst/>
-          </a:prstGeom>
-          <a:noFill/>
-          <a:ln/>
-        </p:spPr>
-        <p:txBody>
-          <a:bodyPr wrap="square" lIns="0" tIns="0" rIns="0" bIns="0" rtlCol="0" anchor="ctr"/>
-          <a:lstStyle/>
-          <a:p>
-            <a:pPr indent="0" marL="0">
-              <a:buNone/>
-            </a:pPr>
-            <a:r>
-              <a:rPr lang="en-US" sz="800" b="1" spc="140" kern="0" dirty="0">
-                <a:solidFill>
-                  <a:srgbClr val="A6A6AC"/>
-                </a:solidFill>
-                <a:latin typeface="Calibri" pitchFamily="34" charset="0"/>
-                <a:ea typeface="Calibri" pitchFamily="34" charset="-122"/>
-                <a:cs typeface="Calibri" pitchFamily="34" charset="-120"/>
-              </a:rPr>
-              <a:t>MEKÂNSAL TALEP</a:t>
-            </a:r>
-            <a:endParaRPr lang="en-US" sz="800" dirty="0"/>
-          </a:p>
-        </p:txBody>
-      </p:sp>
-      <p:sp>
-        <p:nvSpPr>
-          <p:cNvPr id="25" name="Text 23"/>
-          <p:cNvSpPr txBox="1"/>
-          <p:nvPr/>
-        </p:nvSpPr>
-        <p:spPr>
-          <a:xfrm>
-            <a:off x="9144000" y="4343400"/>
-            <a:ext cx="2048256" cy="365760"/>
-          </a:xfrm>
-          <a:prstGeom prst="rect">
-            <a:avLst/>
-          </a:prstGeom>
-          <a:noFill/>
-          <a:ln/>
-        </p:spPr>
-        <p:txBody>
-          <a:bodyPr wrap="square" lIns="0" tIns="0" rIns="0" bIns="0" rtlCol="0" anchor="ctr"/>
-          <a:lstStyle/>
-          <a:p>
-            <a:pPr indent="0" marL="0">
-              <a:lnSpc>
-                <a:spcPts val="1250"/>
-              </a:lnSpc>
-              <a:buNone/>
-            </a:pPr>
-            <a:r>
-              <a:rPr lang="en-US" sz="1000" dirty="0">
-                <a:solidFill>
-                  <a:srgbClr val="8C3A2B"/>
-                </a:solidFill>
-                <a:latin typeface="Calibri" pitchFamily="34" charset="0"/>
-                <a:ea typeface="Calibri" pitchFamily="34" charset="-122"/>
-                <a:cs typeface="Calibri" pitchFamily="34" charset="-120"/>
-              </a:rPr>
-              <a:t>esnek teşhir · kampanya alanı · değişebilir düzen</a:t>
-            </a:r>
-            <a:endParaRPr lang="en-US" sz="1000" dirty="0"/>
-          </a:p>
-        </p:txBody>
-      </p:sp>
-      <p:sp>
-        <p:nvSpPr>
-          <p:cNvPr id="26" name="Text 24"/>
-          <p:cNvSpPr txBox="1"/>
-          <p:nvPr/>
-        </p:nvSpPr>
-        <p:spPr>
-          <a:xfrm>
-            <a:off x="777240" y="5029200"/>
-            <a:ext cx="10424160" cy="411480"/>
-          </a:xfrm>
-          <a:prstGeom prst="rect">
-            <a:avLst/>
-          </a:prstGeom>
-          <a:noFill/>
-          <a:ln/>
-        </p:spPr>
-        <p:txBody>
-          <a:bodyPr wrap="square" lIns="0" tIns="0" rIns="0" bIns="0" rtlCol="0" anchor="ctr"/>
-          <a:lstStyle/>
-          <a:p>
-            <a:pPr algn="l" indent="0" marL="0">
-              <a:lnSpc>
-                <a:spcPts val="1200"/>
-              </a:lnSpc>
-              <a:buNone/>
-            </a:pPr>
-            <a:r>
-              <a:rPr lang="en-US" sz="1300" i="1" dirty="0">
-                <a:solidFill>
-                  <a:srgbClr val="8C3A2B"/>
-                </a:solidFill>
-                <a:latin typeface="Cambria" pitchFamily="34" charset="0"/>
-                <a:ea typeface="Cambria" pitchFamily="34" charset="-122"/>
-                <a:cs typeface="Cambria" pitchFamily="34" charset="-120"/>
-              </a:rPr>
-              <a:t>Her deneyim türü mekânda yer kaplar. Bir mağaza dördünü birden iyi yapamaz; hangisini seçtiği bir tasarım kararıdır.</a:t>
-            </a:r>
-            <a:endParaRPr lang="en-US" sz="1300" dirty="0"/>
-          </a:p>
-        </p:txBody>
-      </p:sp>
-      <p:sp>
-        <p:nvSpPr>
-          <p:cNvPr id="27" name="Text 25"/>
-          <p:cNvSpPr txBox="1"/>
-          <p:nvPr/>
-        </p:nvSpPr>
-        <p:spPr>
-          <a:xfrm>
-            <a:off x="777240" y="5577840"/>
-            <a:ext cx="10424160" cy="548640"/>
-          </a:xfrm>
-          <a:prstGeom prst="rect">
-            <a:avLst/>
-          </a:prstGeom>
-          <a:noFill/>
-          <a:ln/>
-        </p:spPr>
-        <p:txBody>
-          <a:bodyPr wrap="square" lIns="0" tIns="0" rIns="0" bIns="0" rtlCol="0" anchor="ctr"/>
-          <a:lstStyle/>
-          <a:p>
-            <a:pPr indent="0" marL="0">
-              <a:lnSpc>
-                <a:spcPts val="2300"/>
-              </a:lnSpc>
-              <a:buNone/>
-            </a:pPr>
-            <a:r>
-              <a:rPr lang="en-US" sz="1200" dirty="0">
-                <a:solidFill>
-                  <a:srgbClr val="2B2B31"/>
-                </a:solidFill>
-                <a:latin typeface="Cambria" pitchFamily="34" charset="0"/>
-                <a:ea typeface="Cambria" pitchFamily="34" charset="-122"/>
-                <a:cs typeface="Cambria" pitchFamily="34" charset="-120"/>
-              </a:rPr>
-              <a:t>Bu türler çok kanallı perakende üzerine yapılan çalışmalarda, özellikle genç kuşak müşterinin beklentileri üzerinden tanımlanıyor (Xi &amp; Idris, 2026; Lindström, 2005).</a:t>
-            </a:r>
-            <a:endParaRPr lang="en-US" sz="1200" dirty="0"/>
+              <a:t>Her deneyim türü mekânda yer kaplar. Seçilmeyen türün alanını ayırmamak da bir karardır (Lindström, 2005; Xi &amp; Idris, 2026).</a:t>
+            </a:r>
+            <a:endParaRPr lang="en-US" sz="1250" dirty="0"/>
           </a:p>
         </p:txBody>
       </p:sp>

</xml_diff>